<commit_message>
docs(fase-2): guiones de Jorge y Martín y presentación de 10 minutos
La presentación completa dura como máximo 10 minutos, con la demo, y
apunta a 9:30. Jorge presenta las láminas 1 a 13 en 4:45. Martín hace la
demo en 3:45, con seis escenas: ficha, enlace y PIN, relevo con el aviso
"Tus datos en MATU", Quién la vio, qué se está acabando y el pedido con
un solo cobro. Después cierra las láminas 15 a 17 en 1:00.

Las notas del orador del .pptx salen del mismo texto que los guiones,
con los segundos y el tiempo acumulado de cada lámina.

Co-Authored-By: Claude Opus 5.5 <noreply@anthropic.com>
</commit_message>
<xml_diff>
--- a/Fase 2/Evidencias Proyecto/MATU_Presentacion_Fase2.pptx
+++ b/Fase 2/Evidencias Proyecto/MATU_Presentacion_Fase2.pptx
@@ -123,57 +123,57 @@
   <p:extLst>
     <p:ext uri="{521415D9-36F7-43E2-AB2F-B90AF26B5E84}">
       <p14:sectionLst xmlns:p14="http://schemas.microsoft.com/office/powerpoint/2010/main">
-        <p14:section name="Portada" id="{f2f7153b-f3ab-f249-5680-b479980f763c}">
+        <p14:section name="Portada" id="{dc31eaa5-0249-ca6b-805c-b50b20efa01d}">
           <p14:sldIdLst>
             <p14:sldId id="256"/>
           </p14:sldIdLst>
         </p14:section>
-        <p14:section name="Equipo" id="{3aafa847-bd0e-51b4-7591-dbc812d05c28}">
+        <p14:section name="Equipo" id="{f60cec05-5050-b67e-b37c-98be6fbdc386}">
           <p14:sldIdLst>
             <p14:sldId id="257"/>
           </p14:sldIdLst>
         </p14:section>
-        <p14:section name="Contexto" id="{7a783648-e9f9-8f5e-97f7-20dd25214f10}">
+        <p14:section name="Contexto" id="{305862f1-b17d-adad-9060-20a02359c15b}">
           <p14:sldIdLst>
             <p14:sldId id="258"/>
           </p14:sldIdLst>
         </p14:section>
-        <p14:section name="Objetivos" id="{0a1d14fd-9b9c-a3e2-f482-ab4760dfed58}">
+        <p14:section name="Objetivos" id="{81b84347-3938-5add-20d2-074181686860}">
           <p14:sldIdLst>
             <p14:sldId id="259"/>
             <p14:sldId id="260"/>
           </p14:sldIdLst>
         </p14:section>
-        <p14:section name="Alcance y requerimientos" id="{80b11b1b-b029-b4fb-c90d-b8f1897973ba}">
+        <p14:section name="Alcance y requerimientos" id="{3163d529-d0ed-b0a9-c9d3-86a4e5298a26}">
           <p14:sldIdLst>
             <p14:sldId id="261"/>
             <p14:sldId id="262"/>
           </p14:sldIdLst>
         </p14:section>
-        <p14:section name="Metodología y cronograma" id="{a62c85cc-5a83-7570-f1f6-13a5d0ae3d83}">
+        <p14:section name="Metodología y cronograma" id="{87e2e867-a3ac-7724-38b4-5a49be3ffccc}">
           <p14:sldIdLst>
             <p14:sldId id="263"/>
             <p14:sldId id="264"/>
           </p14:sldIdLst>
         </p14:section>
-        <p14:section name="Solución técnica" id="{9cd525f6-b312-0de1-2c9e-f734a3589ec9}">
+        <p14:section name="Solución técnica" id="{95388648-6cf4-02ae-da9b-420b6bdd5a67}">
           <p14:sldIdLst>
             <p14:sldId id="265"/>
             <p14:sldId id="266"/>
             <p14:sldId id="267"/>
           </p14:sldIdLst>
         </p14:section>
-        <p14:section name="Negocio" id="{1d37cecf-d2cb-b2e5-e26f-a8ac4a4e870d}">
+        <p14:section name="Negocio" id="{30321be0-6831-46f6-e85c-e9b83b141e47}">
           <p14:sldIdLst>
             <p14:sldId id="268"/>
           </p14:sldIdLst>
         </p14:section>
-        <p14:section name="Demostración" id="{21c0594d-5b8b-6d4a-b7d7-61491afd64fd}">
+        <p14:section name="Demostración" id="{f426fab9-c824-d6a7-a18a-9e0f152965a9}">
           <p14:sldIdLst>
             <p14:sldId id="269"/>
           </p14:sldIdLst>
         </p14:section>
-        <p14:section name="Cierre" id="{828c3894-e5a3-6eab-5c27-ac95835e3ce4}">
+        <p14:section name="Cierre" id="{9ad9a38d-9bfa-180e-e235-531b08f76385}">
           <p14:sldIdLst>
             <p14:sldId id="270"/>
             <p14:sldId id="271"/>
@@ -584,7 +584,7 @@
           <a:p>
             <a:r>
               <a:rPr lang="en-US" dirty="0"/>
-              <a:t>Habla Jorge. Buenas tardes. Somos Jorge Espinoza, Product Owner, y Martín Henríquez, Scrum Master, y presentamos el avance de MATU, un sistema de continuidad del cuidado para personas mayores con dependencia. Yo explico qué problema resuelve y cómo lo resuelve, y Martín muestra la demo en vivo.</a:t>
+              <a:t>Habla Jorge · 12 s · al terminar 0:12. Buenas tardes. Somos Jorge Espinoza y Martín Henríquez. Les presentamos MATU, un sistema de continuidad del cuidado para personas mayores con dependencia.</a:t>
             </a:r>
             <a:endParaRPr lang="en-US" dirty="0"/>
           </a:p>
@@ -672,7 +672,7 @@
           <a:p>
             <a:r>
               <a:rPr lang="en-US" dirty="0"/>
-              <a:t>Habla Jorge. Elegimos tecnología aburrida y documentada, porque aprendemos el stack mientras construimos. El backend es Python con FastAPI sobre PostgreSQL 16 con Row Level Security, el frontend es React con TypeScript, y los pagos van con Webpay Plus. MATU es una app móvil en su visión: en el semestre la construimos como app web mobile first y la app nativa viene después.</a:t>
+              <a:t>Habla Jorge · 15 s · al terminar 3:18. Usamos tecnología conocida: Python con FastAPI, PostgreSQL 16 con Row Level Security, React con TypeScript y Webpay Plus. Cada push pasa por el CI con todas las pruebas.</a:t>
             </a:r>
             <a:endParaRPr lang="en-US" dirty="0"/>
           </a:p>
@@ -760,7 +760,7 @@
           <a:p>
             <a:r>
               <a:rPr lang="en-US" dirty="0"/>
-              <a:t>Habla Jorge. MATU es un monolito modular: una sola API en FastAPI con módulos de límite explícito, porque el volumen del piloto no justifica microservicios. Las dependencias apuntan hacia abajo, así que la capa de despacho se puede quitar y la ficha y la predicción siguen funcionando, y una prueba automática lo verifica. La seguridad es estructural: cada familia aislada con Row Level Security y la ficha cifrada con una clave por persona, según la Ley 21.719.</a:t>
+              <a:t>Habla Jorge · 38 s · al terminar 3:56. La arquitectura es un monolito modular: una API con módulos de límites claros. Las dependencias van siempre hacia abajo. La ficha no sabe que existe el despacho. Por eso la capa 3 se puede quitar y lo demás sigue funcionando, y una prueba automática lo verifica. La seguridad está en el diseño. Cada familia está aislada en la base de datos. La ficha va cifrada, con una clave por persona. Y diseñamos para la Ley 21.719, vigente desde diciembre.</a:t>
             </a:r>
             <a:endParaRPr lang="en-US" dirty="0"/>
           </a:p>
@@ -848,7 +848,7 @@
           <a:p>
             <a:r>
               <a:rPr lang="en-US" dirty="0"/>
-              <a:t>Habla Jorge. Todo el modelo cuelga del grupo familiar, que es la unidad de aislamiento: cada tabla de negocio lleva su grupo y PostgreSQL filtra por fila. De la persona cuidada salen la ficha con sus secciones cifradas y sus accesos de relevo, el perfil de consumo con sus avisos y, en la capa que se puede quitar, el pedido y su cobro. Son 49 tablas, 45 con Row Level Security forzado, y 31 pruebas de aislamiento corren en verde contra una base real.</a:t>
+              <a:t>Habla Jorge · 22 s · al terminar 4:18. Todo el modelo cuelga del grupo familiar, que es la unidad de aislamiento. De la persona cuidada salen la ficha, el consumo y el pedido. No guardamos datos clínicos. Son 49 tablas, y 31 pruebas de aislamiento pasan en verde.</a:t>
             </a:r>
             <a:endParaRPr lang="en-US" dirty="0"/>
           </a:p>
@@ -936,7 +936,7 @@
           <a:p>
             <a:r>
               <a:rPr lang="en-US" dirty="0"/>
-              <a:t>Habla Jorge. El despacho por sí solo no sostiene el negocio: deja 1.400 pesos por familia al mes y necesitaría 429 familias para el equilibrio. Con una suscripción de 5.990 pesos el margen sube a 7.210 y el equilibrio baja a 84 familias, que es alcanzable en una comuna. Seis de diez entrevistadas ya pagan por algún servicio de cuidado, pero lo declaramos como ejercicio de viabilidad: el costo de conseguir cada familia sigue sin medirse.</a:t>
+              <a:t>Habla Jorge · 27 s · al terminar 4:45 · pasa la palabra a Martín. ¿Se sostiene? Solo con despacho, no: harían falta 429 familias. Con una suscripción de 5.990 pesos, el equilibrio baja a 84 familias. Seis de diez entrevistadas ya pagan por algún servicio de cuidado. Es un ejercicio de viabilidad, no un compromiso del semestre. Martín les va a mostrar MATU funcionando.</a:t>
             </a:r>
             <a:endParaRPr lang="en-US" dirty="0"/>
           </a:p>
@@ -1024,7 +1024,7 @@
           <a:p>
             <a:r>
               <a:rPr lang="en-US" dirty="0"/>
-              <a:t>Habla Martín, unos 8 minutos. Les muestro MATU funcionando: la cuenta, el grupo y el alta con permiso usan el backend real si está levantado, y el resto corre simulado en memoria, siempre con datos sintéticos. Recorro las tres capas en orden, la ficha con su enlace y PIN, el consumo con la lista y el pedido con un solo cobro, y termino con los casos borde. Si algo falla, la demo pasa sola al modo simulado.</a:t>
+              <a:t>Habla Martín, recibe la palabra de Jorge · demo de 3:45 · al terminar 8:30. Gracias, Jorge. Carmen cuida a su mamá, María. Este fin de semana la reemplaza Rosa. Seis escenas desde la guía («?»): 7 Completar un campo, 10 Enlace y PIN, 11 Relevo: escribe el PIN (aviso «Tus datos en MATU»), 13 Quién la vio («abrió el enlace»), 16 Qué se está acabando y 21 Tu pedido, antes de pagar. Plan B: saltar de escena desde la guía, todo es simulado.</a:t>
             </a:r>
             <a:endParaRPr lang="en-US" dirty="0"/>
           </a:p>
@@ -1112,7 +1112,7 @@
           <a:p>
             <a:r>
               <a:rPr lang="en-US" dirty="0"/>
-              <a:t>Habla Jorge. Lo que dejamos fuera no quedó olvidado: está diseñado en la arquitectura y en el modelo de datos. La primera prioridad de la fase 2 son los medicamentos y el retiro en CESFAM, que fue la demanda más repetida en las entrevistas. Después vienen la app nativa, el pago dividido, la reposición programada, la app de repartidor y los convenios reales con comercios.</a:t>
+              <a:t>Habla Martín · 22 s · al terminar 8:52. Lo que quedó fuera está diseñado. Primero vienen los medicamentos y el retiro en CESFAM, la demanda más repetida. Después, la app nativa, el pago dividido, la reposición programada, la app de repartidor y los comercios reales.</a:t>
             </a:r>
             <a:endParaRPr lang="en-US" dirty="0"/>
           </a:p>
@@ -1200,7 +1200,7 @@
           <a:p>
             <a:r>
               <a:rPr lang="en-US" dirty="0"/>
-              <a:t>Habla Jorge. En resumen: el problema está medido, la solución va en el orden correcto y la seguridad es parte del diseño, no un agregado. También decimos lo que falta: la consulta legal, una figura jurídica para vender y los convenios con comercios. Por eso el semestre entrega un entorno de demostración, y la evidencia de la Fase 1 ya corrigió el producto una vez.</a:t>
+              <a:t>Habla Martín · 25 s · al terminar 9:17. En resumen: el problema está medido, la solución va en orden y la seguridad está en el diseño. Lo que falta: la consulta legal, una figura jurídica para vender y los convenios. Por eso entregamos un entorno de demostración.</a:t>
             </a:r>
             <a:endParaRPr lang="en-US" dirty="0"/>
           </a:p>
@@ -1288,7 +1288,7 @@
           <a:p>
             <a:r>
               <a:rPr lang="en-US" dirty="0"/>
-              <a:t>Habla Jorge. Gracias por su atención. MATU busca que quien cuida pueda salir unas horas sabiendo que quien la reemplaza tiene lo que necesita. Quedamos atentos a sus preguntas.</a:t>
+              <a:t>Habla Martín · 13 s · al terminar 9:30. Gracias. Jorge y yo quedamos atentos a sus preguntas.</a:t>
             </a:r>
             <a:endParaRPr lang="en-US" dirty="0"/>
           </a:p>
@@ -1376,7 +1376,7 @@
           <a:p>
             <a:r>
               <a:rPr lang="en-US" dirty="0"/>
-              <a:t>Habla Jorge. Somos dos y repartimos el trabajo por eje vertical y no por capa: yo llevo el cuidado y el consumo, y Martín la identidad, el dinero y la operación, cada uno de punta a punta. Yo soy Product Owner y Martín es Scrum Master. Nos apoyamos en seis agentes de IA, pero las decisiones y la revisión de cada cambio son siempre nuestras.</a:t>
+              <a:t>Habla Jorge · 18 s · al terminar 0:30. Yo soy Product Owner y llevo el cuidado y el consumo. Martín es Scrum Master y lleva identidad, dinero y operación. Nos apoyamos en seis agentes de IA, pero las decisiones son nuestras.</a:t>
             </a:r>
             <a:endParaRPr lang="en-US" dirty="0"/>
           </a:p>
@@ -1464,7 +1464,7 @@
           <a:p>
             <a:r>
               <a:rPr lang="en-US" dirty="0"/>
-              <a:t>Habla Jorge. En Chile un millón y medio de personas adultas viven con dependencia, y casi todas las cuidan familiares sin pago. Entrevistamos a diez cuidadoras: nueve dejaron de salir por falta de relevo, y seis de nueve relevos fallaron por algo que solo sabía la cuidadora. MATU responde en tres capas y en ese orden: la ficha de relevo, la predicción de cuándo se acaba cada insumo y, como servicio que se puede quitar, el despacho.</a:t>
+              <a:t>Habla Jorge · 38 s · al terminar 1:08. En Chile, casi un millón y medio de personas adultas viven con dependencia. Y el 96,4% de quienes las cuidan en el hogar no recibe pago. Entrevistamos a diez cuidadoras. Nueve de diez dejaron de salir por falta de relevo. Seis de nueve relevos fallaron por algo que solo sabía la cuidadora. Falta poder traspasar el cuidado. MATU lo resuelve en tres capas, en este orden. La ficha de relevo, que es el producto. La predicción de cuándo se acaba cada insumo. Y el despacho, un servicio que se puede quitar.</a:t>
             </a:r>
             <a:endParaRPr lang="en-US" dirty="0"/>
           </a:p>
@@ -1552,7 +1552,7 @@
           <a:p>
             <a:r>
               <a:rPr lang="en-US" dirty="0"/>
-              <a:t>Habla Jorge. Nuestro objetivo general es una plataforma que parte del plan de cuidado, predice cuándo se acaba cada insumo y coordina la reposición y el pago. Al cierre del semestre debe quedar desplegada y operativa en un entorno de demostración, sin dinero real. Es el mismo objetivo que presentamos en la Fase 1.</a:t>
+              <a:t>Habla Jorge · 20 s · al terminar 1:28. Nuestro objetivo general, en corto: una plataforma que parte del plan de cuidado, predice cuándo se acaban los insumos y coordina su reposición y pago. Operativa en un entorno de demostración al cierre del semestre.</a:t>
             </a:r>
             <a:endParaRPr lang="en-US" dirty="0"/>
           </a:p>
@@ -1640,7 +1640,7 @@
           <a:p>
             <a:r>
               <a:rPr lang="en-US" dirty="0"/>
-              <a:t>Habla Jorge. Cada objetivo específico tiene un sprint de cierre, para poder verificarlo y no solo declararlo. Los dos primeros están cumplidos: la validación con diez cuidadoras y el modelo de datos con aislamiento probado. La ficha con su relevo es el sprint 2, que estamos cerrando, y el objetivo de pago cambió con el ADR-027: ahora se cobra una sola vez el total confirmado.</a:t>
+              <a:t>Habla Jorge · 20 s · al terminar 1:48. Son siete objetivos específicos, cada uno con su sprint. Dos ya están cumplidos: la validación y el aislamiento entre familias. El tercero, la ficha con su relevo, es el que verán en la demo. El del pago cambió con el ADR-027: ahora es un solo cobro.</a:t>
             </a:r>
             <a:endParaRPr lang="en-US" dirty="0"/>
           </a:p>
@@ -1728,7 +1728,7 @@
           <a:p>
             <a:r>
               <a:rPr lang="en-US" dirty="0"/>
-              <a:t>Habla Jorge. En el semestre entra lo que nunca se sacrifica: la ficha de relevo, el enlace con PIN, la predicción y la lista exportable, más el pedido con un solo cobro. Las restricciones son reales: somos dos, es un piloto académico sin dinero real y todavía no hay convenios, así que el catálogo es simulado. El pago dividido, la reposición programada, la app de repartidor y los medicamentos quedan diseñados para después.</a:t>
+              <a:t>Habla Jorge · 20 s · al terminar 2:08. Construimos lo que nunca se sacrifica: la ficha, el enlace con PIN, la predicción y la lista. Es un piloto académico, sin dinero real y sin convenios. Y es una app web mobile first: la app nativa viene después.</a:t>
             </a:r>
             <a:endParaRPr lang="en-US" dirty="0"/>
           </a:p>
@@ -1816,7 +1816,7 @@
           <a:p>
             <a:r>
               <a:rPr lang="en-US" dirty="0"/>
-              <a:t>Habla Jorge. De 42 requerimientos funcionales, 26 son obligatorios en el MVP, y los agrupamos por capa: la ficha y su acceso, la predicción y la lista, y el pedido con un solo cobro. Los no funcionales son seis atributos de calidad medibles, y el primero es que ningún pago quede sin registrar. La accesibilidad es un requisito y no un acabado: una persona de 68 años debe completar la ficha en menos de tres minutos con el texto al 200%.</a:t>
+              <a:t>Habla Jorge · 22 s · al terminar 2:30. De 42 requerimientos funcionales, 26 son obligatorios, ordenados por capa. Los no funcionales son seis atributos medibles. El primero: ningún pago sin registrar. Y la accesibilidad es requisito: una persona de 68 años completa la ficha en menos de tres minutos.</a:t>
             </a:r>
             <a:endParaRPr lang="en-US" dirty="0"/>
           </a:p>
@@ -1904,7 +1904,7 @@
           <a:p>
             <a:r>
               <a:rPr lang="en-US" dirty="0"/>
-              <a:t>Habla Jorge. Trabajamos con Scrum en sprints de una semana: planificamos el viernes y revisamos y hacemos la retrospectiva el jueves. Cada historia va en su rama y termina en un pull request que revisa y fusiona la otra persona, con el CI en verde. Desarrollamos con asistencia de IA, y por eso medimos cuánto nos acelera en vez de suponerlo.</a:t>
+              <a:t>Habla Jorge · 18 s · al terminar 2:48. Usamos Scrum con sprints de una semana, de viernes a jueves. Cada cambio termina en un pull request que revisa la otra persona. Y medimos cuánto nos acelera la IA, en vez de suponerlo.</a:t>
             </a:r>
             <a:endParaRPr lang="en-US" dirty="0"/>
           </a:p>
@@ -1992,7 +1992,7 @@
           <a:p>
             <a:r>
               <a:rPr lang="en-US" dirty="0"/>
-              <a:t>Habla Jorge. El sprint 0 se extendió hasta la semana 10 mientras acordábamos el entorno con el profesor, y desde ahí corremos sprints de viernes a jueves. Los sprints 0 y 1 están cerrados y el 2, la ficha y el acceso de relevo, cierra este jueves. Quedan tres sprints de construcción hasta la entrega final de la semana 15, y dos de reserva antes de la Fase 3.</a:t>
+              <a:t>Habla Jorge · 15 s · al terminar 3:03. Los sprints 0 y 1 están cerrados. El 2, la ficha y el relevo, cierra este jueves. Quedan tres de construcción hasta la semana 15, y dos de reserva.</a:t>
             </a:r>
             <a:endParaRPr lang="en-US" dirty="0"/>
           </a:p>

</xml_diff>

<commit_message>
docs(fase-2): ajustes del guion de Martín tras el QA de la demo
- Sin modo presentación: en ese modo desaparece la franja, que tiene
  "Abrir como Rosa" y el PIN de la escena 11.
- Escena 10: el PIN se ve en pantalla y es siempre 4821. En la franja
  aparece recién en la escena 11.
- Escena 11: bajar con la rueda del mouse antes de señalar el aviso
  "Tus datos en MATU", que a 1280x720 queda bajo el borde.
- Escena 16: exportar la lista solo se dice, porque el botón está en la
  escena 20.

Los tiempos no cambian (demo de 3:45). La nota de la lámina 15 del .pptx
sale del mismo texto.

Co-Authored-By: Claude Opus 5.5 <noreply@anthropic.com>
</commit_message>
<xml_diff>
--- a/Fase 2/Evidencias Proyecto/MATU_Presentacion_Fase2.pptx
+++ b/Fase 2/Evidencias Proyecto/MATU_Presentacion_Fase2.pptx
@@ -124,58 +124,58 @@
   <p:extLst>
     <p:ext uri="{521415D9-36F7-43E2-AB2F-B90AF26B5E84}">
       <p14:sectionLst xmlns:p14="http://schemas.microsoft.com/office/powerpoint/2010/main">
-        <p14:section name="Portada" id="{9c01a106-0f32-77cb-7140-f3b6626939c7}">
+        <p14:section name="Portada" id="{581eb513-1109-f6c2-413a-9e45ebc0ce65}">
           <p14:sldIdLst>
             <p14:sldId id="256"/>
           </p14:sldIdLst>
         </p14:section>
-        <p14:section name="Equipo" id="{a1008a74-469b-0d47-7e99-f92ebf2495e6}">
+        <p14:section name="Equipo" id="{7e08e7d8-691b-dd78-a3a1-c9f4acccf550}">
           <p14:sldIdLst>
             <p14:sldId id="257"/>
           </p14:sldIdLst>
         </p14:section>
-        <p14:section name="Contexto" id="{cfcf639f-b2c3-0999-5255-459f3e8650a8}">
+        <p14:section name="Contexto" id="{ec740d5b-ead4-9d14-b46d-331648fde4b7}">
           <p14:sldIdLst>
             <p14:sldId id="258"/>
           </p14:sldIdLst>
         </p14:section>
-        <p14:section name="Objetivos" id="{b9bcd56b-22fc-1a15-c994-4d818eb28a34}">
+        <p14:section name="Objetivos" id="{d1e67c8e-dfea-92c4-b336-4b80fd1a3f97}">
           <p14:sldIdLst>
             <p14:sldId id="259"/>
             <p14:sldId id="260"/>
           </p14:sldIdLst>
         </p14:section>
-        <p14:section name="Alcance y requerimientos" id="{524eab8f-0305-e10e-5a72-8bdaa003e226}">
+        <p14:section name="Alcance y requerimientos" id="{1ca6e216-2916-5ea4-294d-55954fd55c9f}">
           <p14:sldIdLst>
             <p14:sldId id="261"/>
             <p14:sldId id="262"/>
             <p14:sldId id="263"/>
           </p14:sldIdLst>
         </p14:section>
-        <p14:section name="Metodología y cronograma" id="{06042c99-9ab8-0ba5-0cfc-526a94afa542}">
+        <p14:section name="Metodología y cronograma" id="{b04d5a66-996b-f845-e5df-7153f2969a79}">
           <p14:sldIdLst>
             <p14:sldId id="264"/>
             <p14:sldId id="265"/>
           </p14:sldIdLst>
         </p14:section>
-        <p14:section name="Solución técnica" id="{7b4a96a2-0d07-7b92-24dc-e8ec7a3be7f4}">
+        <p14:section name="Solución técnica" id="{3f8ecfc2-800b-269a-521a-2eb6052917bc}">
           <p14:sldIdLst>
             <p14:sldId id="266"/>
             <p14:sldId id="267"/>
             <p14:sldId id="268"/>
           </p14:sldIdLst>
         </p14:section>
-        <p14:section name="Negocio" id="{659066c3-2aa3-c8cb-d964-947daca8590d}">
+        <p14:section name="Negocio" id="{571efd4a-46be-57a4-ba1d-35c2161d52c6}">
           <p14:sldIdLst>
             <p14:sldId id="269"/>
           </p14:sldIdLst>
         </p14:section>
-        <p14:section name="Demostración" id="{34dcd5c0-4afd-db56-cd0e-62e06e736109}">
+        <p14:section name="Demostración" id="{da4c93b1-449d-c605-80a3-2f44102afe73}">
           <p14:sldIdLst>
             <p14:sldId id="270"/>
           </p14:sldIdLst>
         </p14:section>
-        <p14:section name="Cierre" id="{1dc7b6e8-0663-63cc-668c-3ed678102cf2}">
+        <p14:section name="Cierre" id="{50cedaa5-aca3-cc0f-2715-8abb37ab008d}">
           <p14:sldIdLst>
             <p14:sldId id="271"/>
             <p14:sldId id="272"/>
@@ -1114,7 +1114,7 @@
           <a:p>
             <a:r>
               <a:rPr lang="en-US" dirty="0"/>
-              <a:t>Habla Martín, recibe la palabra de Jorge · demo de 3:45 · al terminar 8:30. Gracias, Jorge. Carmen cuida a su mamá, María. Este fin de semana la reemplaza Rosa. Seis escenas desde la guía («?»): 7 Completar un campo, 10 Enlace y PIN, 11 Relevo: escribe el PIN (aviso «Tus datos en MATU»), 13 Quién la vio («abrió el enlace»), 16 Qué se está acabando y 21 Tu pedido, antes de pagar. Plan B: saltar de escena desde la guía, todo es simulado.</a:t>
+              <a:t>Habla Martín, recibe la palabra de Jorge · demo de 3:45 · al terminar 8:30. Gracias, Jorge. Carmen cuida a su mamá, María. Este fin de semana la reemplaza Rosa. Seis escenas desde la guía («?»): 7 Completar un campo, 10 Enlace y PIN, 11 Relevo: escribe el PIN (aviso «Tus datos en MATU»), 13 Quién la vio («abrió el enlace»), 16 Qué se está acabando y 21 Tu pedido, antes de pagar. Sin modo presentación: «Abrir como Rosa» está en la franja. El PIN es siempre 4821. Plan B: saltar de escena desde la guía, todo es simulado.</a:t>
             </a:r>
             <a:endParaRPr lang="en-US" dirty="0"/>
           </a:p>

</xml_diff>

<commit_message>
docs(fase-2): la lámina 14 muestra las seis escenas de la demo
Las tarjetas de la demo listaban el recorrido largo. Ahora muestran las
seis escenas del guion de Martín, agrupadas por capa: 7, 10, 11 y 13 en la
capa 1, 16 en la capa 2 y 21 en la capa 3, con textos cortos. La nota y
los tiempos no cambian.

Co-Authored-By: Claude Opus 5.5 <noreply@anthropic.com>
</commit_message>
<xml_diff>
--- a/Fase 2/Evidencias Proyecto/MATU_Presentacion_Fase2.pptx
+++ b/Fase 2/Evidencias Proyecto/MATU_Presentacion_Fase2.pptx
@@ -123,57 +123,57 @@
   <p:extLst>
     <p:ext uri="{521415D9-36F7-43E2-AB2F-B90AF26B5E84}">
       <p14:sectionLst xmlns:p14="http://schemas.microsoft.com/office/powerpoint/2010/main">
-        <p14:section name="Portada" id="{165469a6-98ea-6d1d-9836-7fcd6dca945d}">
+        <p14:section name="Portada" id="{140bb534-3c1c-1e92-7317-8c571918dfed}">
           <p14:sldIdLst>
             <p14:sldId id="256"/>
           </p14:sldIdLst>
         </p14:section>
-        <p14:section name="Equipo" id="{38e625ee-7cb7-57ee-a555-948ab76eacda}">
+        <p14:section name="Equipo" id="{cb1226ef-13f4-8bb0-dace-4c52a5f41fb1}">
           <p14:sldIdLst>
             <p14:sldId id="257"/>
           </p14:sldIdLst>
         </p14:section>
-        <p14:section name="Contexto" id="{422fed64-d4ac-259f-80b2-863574b3a863}">
+        <p14:section name="Contexto" id="{7e922b10-059f-803b-77c1-7d79505d2818}">
           <p14:sldIdLst>
             <p14:sldId id="258"/>
           </p14:sldIdLst>
         </p14:section>
-        <p14:section name="Objetivos" id="{c78d72c4-9493-c5b7-3675-dc2f011b7d19}">
+        <p14:section name="Objetivos" id="{8afd159f-7eb6-7cc2-8152-cbd5745e4328}">
           <p14:sldIdLst>
             <p14:sldId id="259"/>
             <p14:sldId id="260"/>
           </p14:sldIdLst>
         </p14:section>
-        <p14:section name="Alcance y requerimientos" id="{c5a197f7-b82b-cbc1-178a-a78c7007741f}">
+        <p14:section name="Alcance y requerimientos" id="{cda30fd3-6167-36be-88b9-58a8c5c614fb}">
           <p14:sldIdLst>
             <p14:sldId id="261"/>
             <p14:sldId id="262"/>
           </p14:sldIdLst>
         </p14:section>
-        <p14:section name="Metodología y cronograma" id="{eb0b7d1e-8fae-386d-a7cf-9bb029ebd975}">
+        <p14:section name="Metodología y cronograma" id="{7fdbd57e-3515-5109-d5a0-a1fa9edad268}">
           <p14:sldIdLst>
             <p14:sldId id="263"/>
             <p14:sldId id="264"/>
           </p14:sldIdLst>
         </p14:section>
-        <p14:section name="Solución técnica" id="{18994c7f-b99d-a98f-5dce-767dbd66d7fb}">
+        <p14:section name="Solución técnica" id="{8dceb7c8-3cf3-f5c7-96e2-03ad52f16f4a}">
           <p14:sldIdLst>
             <p14:sldId id="265"/>
             <p14:sldId id="266"/>
             <p14:sldId id="267"/>
           </p14:sldIdLst>
         </p14:section>
-        <p14:section name="Negocio" id="{15b3f779-39af-bce1-c1e8-fdee2d200e18}">
+        <p14:section name="Negocio" id="{dec04c00-7baa-83fd-31ad-5f961845412b}">
           <p14:sldIdLst>
             <p14:sldId id="268"/>
           </p14:sldIdLst>
         </p14:section>
-        <p14:section name="Demostración" id="{1bad2b1a-3032-805d-bc51-75b45767a05b}">
+        <p14:section name="Demostración" id="{26def7a9-e257-7018-98b3-321ea5309c75}">
           <p14:sldIdLst>
             <p14:sldId id="269"/>
           </p14:sldIdLst>
         </p14:section>
-        <p14:section name="Cierre" id="{4afbaa9e-de8d-51d6-2812-6514851f77cc}">
+        <p14:section name="Cierre" id="{be0c7986-1b51-437d-d28e-b037539fde72}">
           <p14:sldIdLst>
             <p14:sldId id="270"/>
             <p14:sldId id="271"/>
@@ -9774,18 +9774,54 @@
       </p:sp>
       <p:sp>
         <p:nvSpPr>
-          <p:cNvPr id="6" name="Ficha de relevo"/>
+          <p:cNvPr id="6" name="Text 4"/>
+          <p:cNvSpPr txBox="1"/>
+          <p:nvPr/>
+        </p:nvSpPr>
+        <p:spPr>
+          <a:xfrm>
+            <a:off x="548640" y="2377440"/>
+            <a:ext cx="6702552" cy="320040"/>
+          </a:xfrm>
+          <a:prstGeom prst="rect">
+            <a:avLst/>
+          </a:prstGeom>
+          <a:noFill/>
+          <a:ln/>
+        </p:spPr>
+        <p:txBody>
+          <a:bodyPr wrap="square" lIns="0" tIns="0" rIns="0" bIns="0" rtlCol="0" anchor="ctr"/>
+          <a:lstStyle/>
+          <a:p>
+            <a:pPr indent="0" marL="0">
+              <a:buNone/>
+            </a:pPr>
+            <a:r>
+              <a:rPr lang="en-US" sz="1600" b="1" dirty="0">
+                <a:solidFill>
+                  <a:schemeClr val="bg1"/>
+                </a:solidFill>
+              </a:rPr>
+              <a:t>Capa 1 · Ficha de relevo</a:t>
+            </a:r>
+            <a:endParaRPr lang="en-US" sz="1600" dirty="0"/>
+          </a:p>
+        </p:txBody>
+      </p:sp>
+      <p:sp>
+        <p:nvSpPr>
+          <p:cNvPr id="7" name="Escena 7"/>
           <p:cNvSpPr/>
           <p:nvPr/>
         </p:nvSpPr>
         <p:spPr>
           <a:xfrm>
-            <a:off x="548640" y="2514600"/>
-            <a:ext cx="2602154" cy="3291840"/>
+            <a:off x="548640" y="2788920"/>
+            <a:ext cx="3236976" cy="1440180"/>
           </a:xfrm>
           <a:prstGeom prst="roundRect">
             <a:avLst>
-              <a:gd name="adj" fmla="val 4217"/>
+              <a:gd name="adj" fmla="val 7619"/>
             </a:avLst>
           </a:prstGeom>
           <a:solidFill>
@@ -9801,14 +9837,14 @@
       </p:sp>
       <p:sp>
         <p:nvSpPr>
-          <p:cNvPr id="7" name="Número"/>
-          <p:cNvSpPr txBox="1"/>
-          <p:nvPr/>
-        </p:nvSpPr>
-        <p:spPr>
-          <a:xfrm>
-            <a:off x="777240" y="2743200"/>
-            <a:ext cx="502920" cy="502920"/>
+          <p:cNvPr id="8" name="Número"/>
+          <p:cNvSpPr txBox="1"/>
+          <p:nvPr/>
+        </p:nvSpPr>
+        <p:spPr>
+          <a:xfrm>
+            <a:off x="777240" y="3017520"/>
+            <a:ext cx="548640" cy="548640"/>
           </a:xfrm>
           <a:prstGeom prst="ellipse">
             <a:avLst/>
@@ -9830,20 +9866,20 @@
               <a:buNone/>
             </a:pPr>
             <a:r>
-              <a:rPr lang="en-US" sz="1900" b="1" dirty="0">
+              <a:rPr lang="en-US" sz="2000" b="1" dirty="0">
                 <a:solidFill>
                   <a:schemeClr val="bg1"/>
                 </a:solidFill>
               </a:rPr>
-              <a:t>1</a:t>
-            </a:r>
-            <a:endParaRPr lang="en-US" sz="1900" dirty="0"/>
+              <a:t>7</a:t>
+            </a:r>
+            <a:endParaRPr lang="en-US" sz="2000" dirty="0"/>
           </a:p>
         </p:txBody>
       </p:sp>
       <p:pic>
         <p:nvPicPr>
-          <p:cNvPr id="8" name="Image 0" descr="Ficha de relevo">    </p:cNvPr>
+          <p:cNvPr id="9" name="Image 0" descr="Completar la ficha">    </p:cNvPr>
           <p:cNvPicPr>
             <a:picLocks noChangeAspect="1"/>
           </p:cNvPicPr>
@@ -9857,7 +9893,7 @@
         </p:blipFill>
         <p:spPr>
           <a:xfrm>
-            <a:off x="2464994" y="2788920"/>
+            <a:off x="3145536" y="3063240"/>
             <a:ext cx="411480" cy="411480"/>
           </a:xfrm>
           <a:prstGeom prst="rect">
@@ -9867,14 +9903,50 @@
       </p:pic>
       <p:sp>
         <p:nvSpPr>
-          <p:cNvPr id="9" name="Text 6"/>
-          <p:cNvSpPr txBox="1"/>
-          <p:nvPr/>
-        </p:nvSpPr>
-        <p:spPr>
-          <a:xfrm>
-            <a:off x="777240" y="3429000"/>
-            <a:ext cx="2144954" cy="731520"/>
+          <p:cNvPr id="10" name="Text 7"/>
+          <p:cNvSpPr txBox="1"/>
+          <p:nvPr/>
+        </p:nvSpPr>
+        <p:spPr>
+          <a:xfrm>
+            <a:off x="1463040" y="2990088"/>
+            <a:ext cx="1591056" cy="603504"/>
+          </a:xfrm>
+          <a:prstGeom prst="rect">
+            <a:avLst/>
+          </a:prstGeom>
+          <a:noFill/>
+          <a:ln/>
+        </p:spPr>
+        <p:txBody>
+          <a:bodyPr wrap="square" lIns="0" tIns="0" rIns="0" bIns="0" rtlCol="0" anchor="ctr"/>
+          <a:lstStyle/>
+          <a:p>
+            <a:pPr indent="0" marL="0">
+              <a:buNone/>
+            </a:pPr>
+            <a:r>
+              <a:rPr lang="en-US" sz="1900" b="1" dirty="0">
+                <a:solidFill>
+                  <a:schemeClr val="tx2"/>
+                </a:solidFill>
+              </a:rPr>
+              <a:t>Completar la ficha</a:t>
+            </a:r>
+            <a:endParaRPr lang="en-US" sz="1900" dirty="0"/>
+          </a:p>
+        </p:txBody>
+      </p:sp>
+      <p:sp>
+        <p:nvSpPr>
+          <p:cNvPr id="11" name="Text 8"/>
+          <p:cNvSpPr txBox="1"/>
+          <p:nvPr/>
+        </p:nvSpPr>
+        <p:spPr>
+          <a:xfrm>
+            <a:off x="777240" y="3657600"/>
+            <a:ext cx="2779776" cy="411480"/>
           </a:xfrm>
           <a:prstGeom prst="rect">
             <a:avLst/>
@@ -9890,48 +9962,12 @@
               <a:buNone/>
             </a:pPr>
             <a:r>
-              <a:rPr lang="en-US" sz="1900" b="1" dirty="0">
-                <a:solidFill>
-                  <a:schemeClr val="tx2"/>
-                </a:solidFill>
-              </a:rPr>
-              <a:t>Ficha de relevo</a:t>
-            </a:r>
-            <a:endParaRPr lang="en-US" sz="1900" dirty="0"/>
-          </a:p>
-        </p:txBody>
-      </p:sp>
-      <p:sp>
-        <p:nvSpPr>
-          <p:cNvPr id="10" name="Text 7"/>
-          <p:cNvSpPr txBox="1"/>
-          <p:nvPr/>
-        </p:nvSpPr>
-        <p:spPr>
-          <a:xfrm>
-            <a:off x="777240" y="4206240"/>
-            <a:ext cx="2144954" cy="1508760"/>
-          </a:xfrm>
-          <a:prstGeom prst="rect">
-            <a:avLst/>
-          </a:prstGeom>
-          <a:noFill/>
-          <a:ln/>
-        </p:spPr>
-        <p:txBody>
-          <a:bodyPr wrap="square" lIns="0" tIns="0" rIns="0" bIns="0" rtlCol="0" anchor="t"/>
-          <a:lstStyle/>
-          <a:p>
-            <a:pPr indent="0" marL="0">
-              <a:buNone/>
-            </a:pPr>
-            <a:r>
               <a:rPr lang="en-US" sz="1500" dirty="0">
                 <a:solidFill>
                   <a:schemeClr val="tx1"/>
                 </a:solidFill>
               </a:rPr>
-              <a:t>Cuenta, permiso, los tres campos, compartir con PIN, el relevo la abre, "Quién la vio" y cortar el enlace</a:t>
+              <a:t>Su día, si se altera y a quién llamar</a:t>
             </a:r>
             <a:endParaRPr lang="en-US" sz="1500" dirty="0"/>
           </a:p>
@@ -9939,18 +9975,18 @@
       </p:sp>
       <p:sp>
         <p:nvSpPr>
-          <p:cNvPr id="11" name="Consumo y predicción"/>
+          <p:cNvPr id="12" name="Escena 10"/>
           <p:cNvSpPr/>
           <p:nvPr/>
         </p:nvSpPr>
         <p:spPr>
           <a:xfrm>
-            <a:off x="3379394" y="2514600"/>
-            <a:ext cx="2602154" cy="3291840"/>
+            <a:off x="4014216" y="2788920"/>
+            <a:ext cx="3236976" cy="1440180"/>
           </a:xfrm>
           <a:prstGeom prst="roundRect">
             <a:avLst>
-              <a:gd name="adj" fmla="val 4217"/>
+              <a:gd name="adj" fmla="val 7619"/>
             </a:avLst>
           </a:prstGeom>
           <a:solidFill>
@@ -9966,14 +10002,14 @@
       </p:sp>
       <p:sp>
         <p:nvSpPr>
-          <p:cNvPr id="12" name="Número"/>
-          <p:cNvSpPr txBox="1"/>
-          <p:nvPr/>
-        </p:nvSpPr>
-        <p:spPr>
-          <a:xfrm>
-            <a:off x="3607994" y="2743200"/>
-            <a:ext cx="502920" cy="502920"/>
+          <p:cNvPr id="13" name="Número"/>
+          <p:cNvSpPr txBox="1"/>
+          <p:nvPr/>
+        </p:nvSpPr>
+        <p:spPr>
+          <a:xfrm>
+            <a:off x="4242816" y="3017520"/>
+            <a:ext cx="548640" cy="548640"/>
           </a:xfrm>
           <a:prstGeom prst="ellipse">
             <a:avLst/>
@@ -9995,20 +10031,20 @@
               <a:buNone/>
             </a:pPr>
             <a:r>
-              <a:rPr lang="en-US" sz="1900" b="1" dirty="0">
+              <a:rPr lang="en-US" sz="2000" b="1" dirty="0">
                 <a:solidFill>
                   <a:schemeClr val="bg1"/>
                 </a:solidFill>
               </a:rPr>
-              <a:t>2</a:t>
-            </a:r>
-            <a:endParaRPr lang="en-US" sz="1900" dirty="0"/>
+              <a:t>10</a:t>
+            </a:r>
+            <a:endParaRPr lang="en-US" sz="2000" dirty="0"/>
           </a:p>
         </p:txBody>
       </p:sp>
       <p:pic>
         <p:nvPicPr>
-          <p:cNvPr id="13" name="Image 1" descr="Consumo y predicción">    </p:cNvPr>
+          <p:cNvPr id="14" name="Image 1" descr="Enlace y PIN">    </p:cNvPr>
           <p:cNvPicPr>
             <a:picLocks noChangeAspect="1"/>
           </p:cNvPicPr>
@@ -10022,7 +10058,7 @@
         </p:blipFill>
         <p:spPr>
           <a:xfrm>
-            <a:off x="5295748" y="2788920"/>
+            <a:off x="6611112" y="3063240"/>
             <a:ext cx="411480" cy="411480"/>
           </a:xfrm>
           <a:prstGeom prst="rect">
@@ -10032,14 +10068,50 @@
       </p:pic>
       <p:sp>
         <p:nvSpPr>
-          <p:cNvPr id="14" name="Text 10"/>
-          <p:cNvSpPr txBox="1"/>
-          <p:nvPr/>
-        </p:nvSpPr>
-        <p:spPr>
-          <a:xfrm>
-            <a:off x="3607994" y="3429000"/>
-            <a:ext cx="2144954" cy="731520"/>
+          <p:cNvPr id="15" name="Text 11"/>
+          <p:cNvSpPr txBox="1"/>
+          <p:nvPr/>
+        </p:nvSpPr>
+        <p:spPr>
+          <a:xfrm>
+            <a:off x="4928616" y="2990088"/>
+            <a:ext cx="1591056" cy="603504"/>
+          </a:xfrm>
+          <a:prstGeom prst="rect">
+            <a:avLst/>
+          </a:prstGeom>
+          <a:noFill/>
+          <a:ln/>
+        </p:spPr>
+        <p:txBody>
+          <a:bodyPr wrap="square" lIns="0" tIns="0" rIns="0" bIns="0" rtlCol="0" anchor="ctr"/>
+          <a:lstStyle/>
+          <a:p>
+            <a:pPr indent="0" marL="0">
+              <a:buNone/>
+            </a:pPr>
+            <a:r>
+              <a:rPr lang="en-US" sz="1900" b="1" dirty="0">
+                <a:solidFill>
+                  <a:schemeClr val="tx2"/>
+                </a:solidFill>
+              </a:rPr>
+              <a:t>Enlace y PIN</a:t>
+            </a:r>
+            <a:endParaRPr lang="en-US" sz="1900" dirty="0"/>
+          </a:p>
+        </p:txBody>
+      </p:sp>
+      <p:sp>
+        <p:nvSpPr>
+          <p:cNvPr id="16" name="Text 12"/>
+          <p:cNvSpPr txBox="1"/>
+          <p:nvPr/>
+        </p:nvSpPr>
+        <p:spPr>
+          <a:xfrm>
+            <a:off x="4242816" y="3657600"/>
+            <a:ext cx="2779776" cy="411480"/>
           </a:xfrm>
           <a:prstGeom prst="rect">
             <a:avLst/>
@@ -10055,48 +10127,12 @@
               <a:buNone/>
             </a:pPr>
             <a:r>
-              <a:rPr lang="en-US" sz="1900" b="1" dirty="0">
-                <a:solidFill>
-                  <a:schemeClr val="tx2"/>
-                </a:solidFill>
-              </a:rPr>
-              <a:t>Consumo y predicción</a:t>
-            </a:r>
-            <a:endParaRPr lang="en-US" sz="1900" dirty="0"/>
-          </a:p>
-        </p:txBody>
-      </p:sp>
-      <p:sp>
-        <p:nvSpPr>
-          <p:cNvPr id="15" name="Text 11"/>
-          <p:cNvSpPr txBox="1"/>
-          <p:nvPr/>
-        </p:nvSpPr>
-        <p:spPr>
-          <a:xfrm>
-            <a:off x="3607994" y="4206240"/>
-            <a:ext cx="2144954" cy="1508760"/>
-          </a:xfrm>
-          <a:prstGeom prst="rect">
-            <a:avLst/>
-          </a:prstGeom>
-          <a:noFill/>
-          <a:ln/>
-        </p:spPr>
-        <p:txBody>
-          <a:bodyPr wrap="square" lIns="0" tIns="0" rIns="0" bIns="0" rtlCol="0" anchor="t"/>
-          <a:lstStyle/>
-          <a:p>
-            <a:pPr indent="0" marL="0">
-              <a:buNone/>
-            </a:pPr>
-            <a:r>
               <a:rPr lang="en-US" sz="1500" dirty="0">
                 <a:solidFill>
                   <a:schemeClr val="tx1"/>
                 </a:solidFill>
               </a:rPr>
-              <a:t>Qué se está acabando, declarar el consumo, "Ya lo compré" y la lista para exportar o compartir</a:t>
+              <a:t>El PIN se ve una sola vez</a:t>
             </a:r>
             <a:endParaRPr lang="en-US" sz="1500" dirty="0"/>
           </a:p>
@@ -10104,18 +10140,18 @@
       </p:sp>
       <p:sp>
         <p:nvSpPr>
-          <p:cNvPr id="16" name="Pedido y pago"/>
+          <p:cNvPr id="17" name="Escena 11"/>
           <p:cNvSpPr/>
           <p:nvPr/>
         </p:nvSpPr>
         <p:spPr>
           <a:xfrm>
-            <a:off x="6210148" y="2514600"/>
-            <a:ext cx="2602154" cy="3291840"/>
+            <a:off x="548640" y="4457700"/>
+            <a:ext cx="3236976" cy="1440180"/>
           </a:xfrm>
           <a:prstGeom prst="roundRect">
             <a:avLst>
-              <a:gd name="adj" fmla="val 4217"/>
+              <a:gd name="adj" fmla="val 7619"/>
             </a:avLst>
           </a:prstGeom>
           <a:solidFill>
@@ -10131,14 +10167,14 @@
       </p:sp>
       <p:sp>
         <p:nvSpPr>
-          <p:cNvPr id="17" name="Número"/>
-          <p:cNvSpPr txBox="1"/>
-          <p:nvPr/>
-        </p:nvSpPr>
-        <p:spPr>
-          <a:xfrm>
-            <a:off x="6438748" y="2743200"/>
-            <a:ext cx="502920" cy="502920"/>
+          <p:cNvPr id="18" name="Número"/>
+          <p:cNvSpPr txBox="1"/>
+          <p:nvPr/>
+        </p:nvSpPr>
+        <p:spPr>
+          <a:xfrm>
+            <a:off x="777240" y="4686300"/>
+            <a:ext cx="548640" cy="548640"/>
           </a:xfrm>
           <a:prstGeom prst="ellipse">
             <a:avLst/>
@@ -10160,20 +10196,20 @@
               <a:buNone/>
             </a:pPr>
             <a:r>
-              <a:rPr lang="en-US" sz="1900" b="1" dirty="0">
+              <a:rPr lang="en-US" sz="2000" b="1" dirty="0">
                 <a:solidFill>
                   <a:schemeClr val="bg1"/>
                 </a:solidFill>
               </a:rPr>
-              <a:t>3</a:t>
-            </a:r>
-            <a:endParaRPr lang="en-US" sz="1900" dirty="0"/>
+              <a:t>11</a:t>
+            </a:r>
+            <a:endParaRPr lang="en-US" sz="2000" dirty="0"/>
           </a:p>
         </p:txBody>
       </p:sp>
       <p:pic>
         <p:nvPicPr>
-          <p:cNvPr id="18" name="Image 2" descr="Pedido y pago">    </p:cNvPr>
+          <p:cNvPr id="19" name="Image 2" descr="El relevo abre">    </p:cNvPr>
           <p:cNvPicPr>
             <a:picLocks noChangeAspect="1"/>
           </p:cNvPicPr>
@@ -10187,7 +10223,7 @@
         </p:blipFill>
         <p:spPr>
           <a:xfrm>
-            <a:off x="8126501" y="2788920"/>
+            <a:off x="3145536" y="4732020"/>
             <a:ext cx="411480" cy="411480"/>
           </a:xfrm>
           <a:prstGeom prst="rect">
@@ -10197,14 +10233,50 @@
       </p:pic>
       <p:sp>
         <p:nvSpPr>
-          <p:cNvPr id="19" name="Text 14"/>
-          <p:cNvSpPr txBox="1"/>
-          <p:nvPr/>
-        </p:nvSpPr>
-        <p:spPr>
-          <a:xfrm>
-            <a:off x="6438748" y="3429000"/>
-            <a:ext cx="2144954" cy="731520"/>
+          <p:cNvPr id="20" name="Text 15"/>
+          <p:cNvSpPr txBox="1"/>
+          <p:nvPr/>
+        </p:nvSpPr>
+        <p:spPr>
+          <a:xfrm>
+            <a:off x="1463040" y="4658868"/>
+            <a:ext cx="1591056" cy="603504"/>
+          </a:xfrm>
+          <a:prstGeom prst="rect">
+            <a:avLst/>
+          </a:prstGeom>
+          <a:noFill/>
+          <a:ln/>
+        </p:spPr>
+        <p:txBody>
+          <a:bodyPr wrap="square" lIns="0" tIns="0" rIns="0" bIns="0" rtlCol="0" anchor="ctr"/>
+          <a:lstStyle/>
+          <a:p>
+            <a:pPr indent="0" marL="0">
+              <a:buNone/>
+            </a:pPr>
+            <a:r>
+              <a:rPr lang="en-US" sz="1900" b="1" dirty="0">
+                <a:solidFill>
+                  <a:schemeClr val="tx2"/>
+                </a:solidFill>
+              </a:rPr>
+              <a:t>El relevo abre</a:t>
+            </a:r>
+            <a:endParaRPr lang="en-US" sz="1900" dirty="0"/>
+          </a:p>
+        </p:txBody>
+      </p:sp>
+      <p:sp>
+        <p:nvSpPr>
+          <p:cNvPr id="21" name="Text 16"/>
+          <p:cNvSpPr txBox="1"/>
+          <p:nvPr/>
+        </p:nvSpPr>
+        <p:spPr>
+          <a:xfrm>
+            <a:off x="777240" y="5326380"/>
+            <a:ext cx="2779776" cy="411480"/>
           </a:xfrm>
           <a:prstGeom prst="rect">
             <a:avLst/>
@@ -10220,48 +10292,12 @@
               <a:buNone/>
             </a:pPr>
             <a:r>
-              <a:rPr lang="en-US" sz="1900" b="1" dirty="0">
-                <a:solidFill>
-                  <a:schemeClr val="tx2"/>
-                </a:solidFill>
-              </a:rPr>
-              <a:t>Pedido y pago</a:t>
-            </a:r>
-            <a:endParaRPr lang="en-US" sz="1900" dirty="0"/>
-          </a:p>
-        </p:txBody>
-      </p:sp>
-      <p:sp>
-        <p:nvSpPr>
-          <p:cNvPr id="20" name="Text 15"/>
-          <p:cNvSpPr txBox="1"/>
-          <p:nvPr/>
-        </p:nvSpPr>
-        <p:spPr>
-          <a:xfrm>
-            <a:off x="6438748" y="4206240"/>
-            <a:ext cx="2144954" cy="1508760"/>
-          </a:xfrm>
-          <a:prstGeom prst="rect">
-            <a:avLst/>
-          </a:prstGeom>
-          <a:noFill/>
-          <a:ln/>
-        </p:spPr>
-        <p:txBody>
-          <a:bodyPr wrap="square" lIns="0" tIns="0" rIns="0" bIns="0" rtlCol="0" anchor="t"/>
-          <a:lstStyle/>
-          <a:p>
-            <a:pPr indent="0" marL="0">
-              <a:buNone/>
-            </a:pPr>
-            <a:r>
               <a:rPr lang="en-US" sz="1500" dirty="0">
                 <a:solidFill>
                   <a:schemeClr val="tx1"/>
                 </a:solidFill>
               </a:rPr>
-              <a:t>El total antes de pagar, la pasarela simulada y la vista de comercio con su código de retiro</a:t>
+              <a:t>Con el aviso «Tus datos en MATU»</a:t>
             </a:r>
             <a:endParaRPr lang="en-US" sz="1500" dirty="0"/>
           </a:p>
@@ -10269,18 +10305,18 @@
       </p:sp>
       <p:sp>
         <p:nvSpPr>
-          <p:cNvPr id="21" name="Casos borde"/>
+          <p:cNvPr id="22" name="Escena 13"/>
           <p:cNvSpPr/>
           <p:nvPr/>
         </p:nvSpPr>
         <p:spPr>
           <a:xfrm>
-            <a:off x="9040901" y="2514600"/>
-            <a:ext cx="2602154" cy="3291840"/>
+            <a:off x="4014216" y="4457700"/>
+            <a:ext cx="3236976" cy="1440180"/>
           </a:xfrm>
           <a:prstGeom prst="roundRect">
             <a:avLst>
-              <a:gd name="adj" fmla="val 4217"/>
+              <a:gd name="adj" fmla="val 7619"/>
             </a:avLst>
           </a:prstGeom>
           <a:solidFill>
@@ -10296,14 +10332,14 @@
       </p:sp>
       <p:sp>
         <p:nvSpPr>
-          <p:cNvPr id="22" name="Número"/>
-          <p:cNvSpPr txBox="1"/>
-          <p:nvPr/>
-        </p:nvSpPr>
-        <p:spPr>
-          <a:xfrm>
-            <a:off x="9269501" y="2743200"/>
-            <a:ext cx="502920" cy="502920"/>
+          <p:cNvPr id="23" name="Número"/>
+          <p:cNvSpPr txBox="1"/>
+          <p:nvPr/>
+        </p:nvSpPr>
+        <p:spPr>
+          <a:xfrm>
+            <a:off x="4242816" y="4686300"/>
+            <a:ext cx="548640" cy="548640"/>
           </a:xfrm>
           <a:prstGeom prst="ellipse">
             <a:avLst/>
@@ -10325,20 +10361,20 @@
               <a:buNone/>
             </a:pPr>
             <a:r>
-              <a:rPr lang="en-US" sz="1900" b="1" dirty="0">
+              <a:rPr lang="en-US" sz="2000" b="1" dirty="0">
                 <a:solidFill>
                   <a:schemeClr val="bg1"/>
                 </a:solidFill>
               </a:rPr>
-              <a:t>4</a:t>
-            </a:r>
-            <a:endParaRPr lang="en-US" sz="1900" dirty="0"/>
+              <a:t>13</a:t>
+            </a:r>
+            <a:endParaRPr lang="en-US" sz="2000" dirty="0"/>
           </a:p>
         </p:txBody>
       </p:sp>
       <p:pic>
         <p:nvPicPr>
-          <p:cNvPr id="23" name="Image 3" descr="Casos borde">    </p:cNvPr>
+          <p:cNvPr id="24" name="Image 3" descr="Quién la vio">    </p:cNvPr>
           <p:cNvPicPr>
             <a:picLocks noChangeAspect="1"/>
           </p:cNvPicPr>
@@ -10352,7 +10388,7 @@
         </p:blipFill>
         <p:spPr>
           <a:xfrm>
-            <a:off x="10957255" y="2788920"/>
+            <a:off x="6611112" y="4732020"/>
             <a:ext cx="411480" cy="411480"/>
           </a:xfrm>
           <a:prstGeom prst="rect">
@@ -10362,14 +10398,50 @@
       </p:pic>
       <p:sp>
         <p:nvSpPr>
-          <p:cNvPr id="24" name="Text 18"/>
-          <p:cNvSpPr txBox="1"/>
-          <p:nvPr/>
-        </p:nvSpPr>
-        <p:spPr>
-          <a:xfrm>
-            <a:off x="9269501" y="3429000"/>
-            <a:ext cx="2144954" cy="731520"/>
+          <p:cNvPr id="25" name="Text 19"/>
+          <p:cNvSpPr txBox="1"/>
+          <p:nvPr/>
+        </p:nvSpPr>
+        <p:spPr>
+          <a:xfrm>
+            <a:off x="4928616" y="4658868"/>
+            <a:ext cx="1591056" cy="603504"/>
+          </a:xfrm>
+          <a:prstGeom prst="rect">
+            <a:avLst/>
+          </a:prstGeom>
+          <a:noFill/>
+          <a:ln/>
+        </p:spPr>
+        <p:txBody>
+          <a:bodyPr wrap="square" lIns="0" tIns="0" rIns="0" bIns="0" rtlCol="0" anchor="ctr"/>
+          <a:lstStyle/>
+          <a:p>
+            <a:pPr indent="0" marL="0">
+              <a:buNone/>
+            </a:pPr>
+            <a:r>
+              <a:rPr lang="en-US" sz="1900" b="1" dirty="0">
+                <a:solidFill>
+                  <a:schemeClr val="tx2"/>
+                </a:solidFill>
+              </a:rPr>
+              <a:t>Quién la vio</a:t>
+            </a:r>
+            <a:endParaRPr lang="en-US" sz="1900" dirty="0"/>
+          </a:p>
+        </p:txBody>
+      </p:sp>
+      <p:sp>
+        <p:nvSpPr>
+          <p:cNvPr id="26" name="Text 20"/>
+          <p:cNvSpPr txBox="1"/>
+          <p:nvPr/>
+        </p:nvSpPr>
+        <p:spPr>
+          <a:xfrm>
+            <a:off x="4242816" y="5326380"/>
+            <a:ext cx="2779776" cy="411480"/>
           </a:xfrm>
           <a:prstGeom prst="rect">
             <a:avLst/>
@@ -10385,12 +10457,177 @@
               <a:buNone/>
             </a:pPr>
             <a:r>
+              <a:rPr lang="en-US" sz="1500" dirty="0">
+                <a:solidFill>
+                  <a:schemeClr val="tx1"/>
+                </a:solidFill>
+              </a:rPr>
+              <a:t>Cada apertura: «abrió el enlace»</a:t>
+            </a:r>
+            <a:endParaRPr lang="en-US" sz="1500" dirty="0"/>
+          </a:p>
+        </p:txBody>
+      </p:sp>
+      <p:sp>
+        <p:nvSpPr>
+          <p:cNvPr id="27" name="Text 21"/>
+          <p:cNvSpPr txBox="1"/>
+          <p:nvPr/>
+        </p:nvSpPr>
+        <p:spPr>
+          <a:xfrm>
+            <a:off x="7525512" y="2377440"/>
+            <a:ext cx="1920240" cy="320040"/>
+          </a:xfrm>
+          <a:prstGeom prst="rect">
+            <a:avLst/>
+          </a:prstGeom>
+          <a:noFill/>
+          <a:ln/>
+        </p:spPr>
+        <p:txBody>
+          <a:bodyPr wrap="square" lIns="0" tIns="0" rIns="0" bIns="0" rtlCol="0" anchor="ctr"/>
+          <a:lstStyle/>
+          <a:p>
+            <a:pPr indent="0" marL="0">
+              <a:buNone/>
+            </a:pPr>
+            <a:r>
+              <a:rPr lang="en-US" sz="1600" b="1" dirty="0">
+                <a:solidFill>
+                  <a:schemeClr val="bg1"/>
+                </a:solidFill>
+              </a:rPr>
+              <a:t>Capa 2 · Consumo</a:t>
+            </a:r>
+            <a:endParaRPr lang="en-US" sz="1600" dirty="0"/>
+          </a:p>
+        </p:txBody>
+      </p:sp>
+      <p:sp>
+        <p:nvSpPr>
+          <p:cNvPr id="28" name="Escena 16"/>
+          <p:cNvSpPr/>
+          <p:nvPr/>
+        </p:nvSpPr>
+        <p:spPr>
+          <a:xfrm>
+            <a:off x="7525512" y="2788920"/>
+            <a:ext cx="1920240" cy="3108960"/>
+          </a:xfrm>
+          <a:prstGeom prst="roundRect">
+            <a:avLst>
+              <a:gd name="adj" fmla="val 5714"/>
+            </a:avLst>
+          </a:prstGeom>
+          <a:solidFill>
+            <a:schemeClr val="bg1"/>
+          </a:solidFill>
+          <a:ln w="12700">
+            <a:solidFill>
+              <a:schemeClr val="bg1"/>
+            </a:solidFill>
+            <a:prstDash val="solid"/>
+          </a:ln>
+        </p:spPr>
+      </p:sp>
+      <p:sp>
+        <p:nvSpPr>
+          <p:cNvPr id="29" name="Número"/>
+          <p:cNvSpPr txBox="1"/>
+          <p:nvPr/>
+        </p:nvSpPr>
+        <p:spPr>
+          <a:xfrm>
+            <a:off x="7754112" y="3017520"/>
+            <a:ext cx="548640" cy="548640"/>
+          </a:xfrm>
+          <a:prstGeom prst="ellipse">
+            <a:avLst/>
+          </a:prstGeom>
+          <a:solidFill>
+            <a:schemeClr val="tx2"/>
+          </a:solidFill>
+          <a:ln>
+            <a:solidFill>
+              <a:schemeClr val="tx2"/>
+            </a:solidFill>
+          </a:ln>
+        </p:spPr>
+        <p:txBody>
+          <a:bodyPr wrap="square" lIns="0" tIns="0" rIns="0" bIns="0" rtlCol="0" anchor="ctr"/>
+          <a:lstStyle/>
+          <a:p>
+            <a:pPr algn="ctr" indent="0" marL="0">
+              <a:buNone/>
+            </a:pPr>
+            <a:r>
+              <a:rPr lang="en-US" sz="2000" b="1" dirty="0">
+                <a:solidFill>
+                  <a:schemeClr val="bg1"/>
+                </a:solidFill>
+              </a:rPr>
+              <a:t>16</a:t>
+            </a:r>
+            <a:endParaRPr lang="en-US" sz="2000" dirty="0"/>
+          </a:p>
+        </p:txBody>
+      </p:sp>
+      <p:pic>
+        <p:nvPicPr>
+          <p:cNvPr id="30" name="Image 4" descr="Qué se está acabando">    </p:cNvPr>
+          <p:cNvPicPr>
+            <a:picLocks noChangeAspect="1"/>
+          </p:cNvPicPr>
+          <p:nvPr/>
+        </p:nvPicPr>
+        <p:blipFill>
+          <a:blip r:embed="rId5"/>
+          <a:stretch>
+            <a:fillRect/>
+          </a:stretch>
+        </p:blipFill>
+        <p:spPr>
+          <a:xfrm>
+            <a:off x="8805672" y="3063240"/>
+            <a:ext cx="411480" cy="411480"/>
+          </a:xfrm>
+          <a:prstGeom prst="rect">
+            <a:avLst/>
+          </a:prstGeom>
+        </p:spPr>
+      </p:pic>
+      <p:sp>
+        <p:nvSpPr>
+          <p:cNvPr id="31" name="Text 24"/>
+          <p:cNvSpPr txBox="1"/>
+          <p:nvPr/>
+        </p:nvSpPr>
+        <p:spPr>
+          <a:xfrm>
+            <a:off x="7754112" y="3794760"/>
+            <a:ext cx="1508760" cy="822960"/>
+          </a:xfrm>
+          <a:prstGeom prst="rect">
+            <a:avLst/>
+          </a:prstGeom>
+          <a:noFill/>
+          <a:ln/>
+        </p:spPr>
+        <p:txBody>
+          <a:bodyPr wrap="square" lIns="0" tIns="0" rIns="0" bIns="0" rtlCol="0" anchor="t"/>
+          <a:lstStyle/>
+          <a:p>
+            <a:pPr indent="0" marL="0">
+              <a:buNone/>
+            </a:pPr>
+            <a:r>
               <a:rPr lang="en-US" sz="1900" b="1" dirty="0">
                 <a:solidFill>
                   <a:schemeClr val="tx2"/>
                 </a:solidFill>
               </a:rPr>
-              <a:t>Casos borde</a:t>
+              <a:t>Qué se está acabando</a:t>
             </a:r>
             <a:endParaRPr lang="en-US" sz="1900" dirty="0"/>
           </a:p>
@@ -10398,14 +10635,14 @@
       </p:sp>
       <p:sp>
         <p:nvSpPr>
-          <p:cNvPr id="25" name="Text 19"/>
-          <p:cNvSpPr txBox="1"/>
-          <p:nvPr/>
-        </p:nvSpPr>
-        <p:spPr>
-          <a:xfrm>
-            <a:off x="9269501" y="4206240"/>
-            <a:ext cx="2144954" cy="1508760"/>
+          <p:cNvPr id="32" name="Text 25"/>
+          <p:cNvSpPr txBox="1"/>
+          <p:nvPr/>
+        </p:nvSpPr>
+        <p:spPr>
+          <a:xfrm>
+            <a:off x="7754112" y="4663440"/>
+            <a:ext cx="1508760" cy="1005840"/>
           </a:xfrm>
           <a:prstGeom prst="rect">
             <a:avLst/>
@@ -10426,7 +10663,208 @@
                   <a:schemeClr val="tx1"/>
                 </a:solidFill>
               </a:rPr>
-              <a:t>Dos versiones de un campo, PIN incorrecto, enlace no disponible y texto al 200%</a:t>
+              <a:t>Cuándo se acaba cada insumo</a:t>
+            </a:r>
+            <a:endParaRPr lang="en-US" sz="1500" dirty="0"/>
+          </a:p>
+        </p:txBody>
+      </p:sp>
+      <p:sp>
+        <p:nvSpPr>
+          <p:cNvPr id="33" name="Text 26"/>
+          <p:cNvSpPr txBox="1"/>
+          <p:nvPr/>
+        </p:nvSpPr>
+        <p:spPr>
+          <a:xfrm>
+            <a:off x="9720072" y="2377440"/>
+            <a:ext cx="1920240" cy="320040"/>
+          </a:xfrm>
+          <a:prstGeom prst="rect">
+            <a:avLst/>
+          </a:prstGeom>
+          <a:noFill/>
+          <a:ln/>
+        </p:spPr>
+        <p:txBody>
+          <a:bodyPr wrap="square" lIns="0" tIns="0" rIns="0" bIns="0" rtlCol="0" anchor="ctr"/>
+          <a:lstStyle/>
+          <a:p>
+            <a:pPr indent="0" marL="0">
+              <a:buNone/>
+            </a:pPr>
+            <a:r>
+              <a:rPr lang="en-US" sz="1600" b="1" dirty="0">
+                <a:solidFill>
+                  <a:schemeClr val="bg1"/>
+                </a:solidFill>
+              </a:rPr>
+              <a:t>Capa 3 · Pedido</a:t>
+            </a:r>
+            <a:endParaRPr lang="en-US" sz="1600" dirty="0"/>
+          </a:p>
+        </p:txBody>
+      </p:sp>
+      <p:sp>
+        <p:nvSpPr>
+          <p:cNvPr id="34" name="Escena 21"/>
+          <p:cNvSpPr/>
+          <p:nvPr/>
+        </p:nvSpPr>
+        <p:spPr>
+          <a:xfrm>
+            <a:off x="9720072" y="2788920"/>
+            <a:ext cx="1920240" cy="3108960"/>
+          </a:xfrm>
+          <a:prstGeom prst="roundRect">
+            <a:avLst>
+              <a:gd name="adj" fmla="val 5714"/>
+            </a:avLst>
+          </a:prstGeom>
+          <a:solidFill>
+            <a:schemeClr val="bg1"/>
+          </a:solidFill>
+          <a:ln w="12700">
+            <a:solidFill>
+              <a:schemeClr val="bg1"/>
+            </a:solidFill>
+            <a:prstDash val="solid"/>
+          </a:ln>
+        </p:spPr>
+      </p:sp>
+      <p:sp>
+        <p:nvSpPr>
+          <p:cNvPr id="35" name="Número"/>
+          <p:cNvSpPr txBox="1"/>
+          <p:nvPr/>
+        </p:nvSpPr>
+        <p:spPr>
+          <a:xfrm>
+            <a:off x="9948672" y="3017520"/>
+            <a:ext cx="548640" cy="548640"/>
+          </a:xfrm>
+          <a:prstGeom prst="ellipse">
+            <a:avLst/>
+          </a:prstGeom>
+          <a:solidFill>
+            <a:schemeClr val="tx2"/>
+          </a:solidFill>
+          <a:ln>
+            <a:solidFill>
+              <a:schemeClr val="tx2"/>
+            </a:solidFill>
+          </a:ln>
+        </p:spPr>
+        <p:txBody>
+          <a:bodyPr wrap="square" lIns="0" tIns="0" rIns="0" bIns="0" rtlCol="0" anchor="ctr"/>
+          <a:lstStyle/>
+          <a:p>
+            <a:pPr algn="ctr" indent="0" marL="0">
+              <a:buNone/>
+            </a:pPr>
+            <a:r>
+              <a:rPr lang="en-US" sz="2000" b="1" dirty="0">
+                <a:solidFill>
+                  <a:schemeClr val="bg1"/>
+                </a:solidFill>
+              </a:rPr>
+              <a:t>21</a:t>
+            </a:r>
+            <a:endParaRPr lang="en-US" sz="2000" dirty="0"/>
+          </a:p>
+        </p:txBody>
+      </p:sp>
+      <p:pic>
+        <p:nvPicPr>
+          <p:cNvPr id="36" name="Image 5" descr="Tu pedido">    </p:cNvPr>
+          <p:cNvPicPr>
+            <a:picLocks noChangeAspect="1"/>
+          </p:cNvPicPr>
+          <p:nvPr/>
+        </p:nvPicPr>
+        <p:blipFill>
+          <a:blip r:embed="rId6"/>
+          <a:stretch>
+            <a:fillRect/>
+          </a:stretch>
+        </p:blipFill>
+        <p:spPr>
+          <a:xfrm>
+            <a:off x="11000232" y="3063240"/>
+            <a:ext cx="411480" cy="411480"/>
+          </a:xfrm>
+          <a:prstGeom prst="rect">
+            <a:avLst/>
+          </a:prstGeom>
+        </p:spPr>
+      </p:pic>
+      <p:sp>
+        <p:nvSpPr>
+          <p:cNvPr id="37" name="Text 29"/>
+          <p:cNvSpPr txBox="1"/>
+          <p:nvPr/>
+        </p:nvSpPr>
+        <p:spPr>
+          <a:xfrm>
+            <a:off x="9948672" y="3794760"/>
+            <a:ext cx="1508760" cy="822960"/>
+          </a:xfrm>
+          <a:prstGeom prst="rect">
+            <a:avLst/>
+          </a:prstGeom>
+          <a:noFill/>
+          <a:ln/>
+        </p:spPr>
+        <p:txBody>
+          <a:bodyPr wrap="square" lIns="0" tIns="0" rIns="0" bIns="0" rtlCol="0" anchor="t"/>
+          <a:lstStyle/>
+          <a:p>
+            <a:pPr indent="0" marL="0">
+              <a:buNone/>
+            </a:pPr>
+            <a:r>
+              <a:rPr lang="en-US" sz="1900" b="1" dirty="0">
+                <a:solidFill>
+                  <a:schemeClr val="tx2"/>
+                </a:solidFill>
+              </a:rPr>
+              <a:t>Tu pedido</a:t>
+            </a:r>
+            <a:endParaRPr lang="en-US" sz="1900" dirty="0"/>
+          </a:p>
+        </p:txBody>
+      </p:sp>
+      <p:sp>
+        <p:nvSpPr>
+          <p:cNvPr id="38" name="Text 30"/>
+          <p:cNvSpPr txBox="1"/>
+          <p:nvPr/>
+        </p:nvSpPr>
+        <p:spPr>
+          <a:xfrm>
+            <a:off x="9948672" y="4663440"/>
+            <a:ext cx="1508760" cy="1005840"/>
+          </a:xfrm>
+          <a:prstGeom prst="rect">
+            <a:avLst/>
+          </a:prstGeom>
+          <a:noFill/>
+          <a:ln/>
+        </p:spPr>
+        <p:txBody>
+          <a:bodyPr wrap="square" lIns="0" tIns="0" rIns="0" bIns="0" rtlCol="0" anchor="t"/>
+          <a:lstStyle/>
+          <a:p>
+            <a:pPr indent="0" marL="0">
+              <a:buNone/>
+            </a:pPr>
+            <a:r>
+              <a:rPr lang="en-US" sz="1500" dirty="0">
+                <a:solidFill>
+                  <a:schemeClr val="tx1"/>
+                </a:solidFill>
+              </a:rPr>
+              <a:t>Precio exacto y un solo cobro</a:t>
             </a:r>
             <a:endParaRPr lang="en-US" sz="1500" dirty="0"/>
           </a:p>

</xml_diff>